<commit_message>
Adds paper to repo
</commit_message>
<xml_diff>
--- a/docs/Diagrams/Diagrams.pptx
+++ b/docs/Diagrams/Diagrams.pptx
@@ -9011,7 +9011,7 @@
           <a:p>
             <a:fld id="{CB18BCE7-0017-4B0C-A2FB-E6F7885367AC}" type="datetimeFigureOut">
               <a:rPr lang="en-IE" smtClean="0"/>
-              <a:t>23/09/2026</a:t>
+              <a:t>07/10/2026</a:t>
             </a:fld>
             <a:endParaRPr lang="en-IE"/>
           </a:p>
@@ -9515,7 +9515,7 @@
           <a:p>
             <a:fld id="{79C0705B-4870-4470-A32F-307AEE1697AB}" type="datetimeFigureOut">
               <a:rPr lang="en-IE" smtClean="0"/>
-              <a:t>23/09/2026</a:t>
+              <a:t>07/10/2026</a:t>
             </a:fld>
             <a:endParaRPr lang="en-IE"/>
           </a:p>
@@ -9685,7 +9685,7 @@
           <a:p>
             <a:fld id="{79C0705B-4870-4470-A32F-307AEE1697AB}" type="datetimeFigureOut">
               <a:rPr lang="en-IE" smtClean="0"/>
-              <a:t>23/09/2026</a:t>
+              <a:t>07/10/2026</a:t>
             </a:fld>
             <a:endParaRPr lang="en-IE"/>
           </a:p>
@@ -9865,7 +9865,7 @@
           <a:p>
             <a:fld id="{79C0705B-4870-4470-A32F-307AEE1697AB}" type="datetimeFigureOut">
               <a:rPr lang="en-IE" smtClean="0"/>
-              <a:t>23/09/2026</a:t>
+              <a:t>07/10/2026</a:t>
             </a:fld>
             <a:endParaRPr lang="en-IE"/>
           </a:p>
@@ -10035,7 +10035,7 @@
           <a:p>
             <a:fld id="{79C0705B-4870-4470-A32F-307AEE1697AB}" type="datetimeFigureOut">
               <a:rPr lang="en-IE" smtClean="0"/>
-              <a:t>23/09/2026</a:t>
+              <a:t>07/10/2026</a:t>
             </a:fld>
             <a:endParaRPr lang="en-IE"/>
           </a:p>
@@ -10281,7 +10281,7 @@
           <a:p>
             <a:fld id="{79C0705B-4870-4470-A32F-307AEE1697AB}" type="datetimeFigureOut">
               <a:rPr lang="en-IE" smtClean="0"/>
-              <a:t>23/09/2026</a:t>
+              <a:t>07/10/2026</a:t>
             </a:fld>
             <a:endParaRPr lang="en-IE"/>
           </a:p>
@@ -10513,7 +10513,7 @@
           <a:p>
             <a:fld id="{79C0705B-4870-4470-A32F-307AEE1697AB}" type="datetimeFigureOut">
               <a:rPr lang="en-IE" smtClean="0"/>
-              <a:t>23/09/2026</a:t>
+              <a:t>07/10/2026</a:t>
             </a:fld>
             <a:endParaRPr lang="en-IE"/>
           </a:p>
@@ -10880,7 +10880,7 @@
           <a:p>
             <a:fld id="{79C0705B-4870-4470-A32F-307AEE1697AB}" type="datetimeFigureOut">
               <a:rPr lang="en-IE" smtClean="0"/>
-              <a:t>23/09/2026</a:t>
+              <a:t>07/10/2026</a:t>
             </a:fld>
             <a:endParaRPr lang="en-IE"/>
           </a:p>
@@ -10998,7 +10998,7 @@
           <a:p>
             <a:fld id="{79C0705B-4870-4470-A32F-307AEE1697AB}" type="datetimeFigureOut">
               <a:rPr lang="en-IE" smtClean="0"/>
-              <a:t>23/09/2026</a:t>
+              <a:t>07/10/2026</a:t>
             </a:fld>
             <a:endParaRPr lang="en-IE"/>
           </a:p>
@@ -11093,7 +11093,7 @@
           <a:p>
             <a:fld id="{79C0705B-4870-4470-A32F-307AEE1697AB}" type="datetimeFigureOut">
               <a:rPr lang="en-IE" smtClean="0"/>
-              <a:t>23/09/2026</a:t>
+              <a:t>07/10/2026</a:t>
             </a:fld>
             <a:endParaRPr lang="en-IE"/>
           </a:p>
@@ -11370,7 +11370,7 @@
           <a:p>
             <a:fld id="{79C0705B-4870-4470-A32F-307AEE1697AB}" type="datetimeFigureOut">
               <a:rPr lang="en-IE" smtClean="0"/>
-              <a:t>23/09/2026</a:t>
+              <a:t>07/10/2026</a:t>
             </a:fld>
             <a:endParaRPr lang="en-IE"/>
           </a:p>
@@ -11627,7 +11627,7 @@
           <a:p>
             <a:fld id="{79C0705B-4870-4470-A32F-307AEE1697AB}" type="datetimeFigureOut">
               <a:rPr lang="en-IE" smtClean="0"/>
-              <a:t>23/09/2026</a:t>
+              <a:t>07/10/2026</a:t>
             </a:fld>
             <a:endParaRPr lang="en-IE"/>
           </a:p>
@@ -11840,7 +11840,7 @@
           <a:p>
             <a:fld id="{79C0705B-4870-4470-A32F-307AEE1697AB}" type="datetimeFigureOut">
               <a:rPr lang="en-IE" smtClean="0"/>
-              <a:t>23/09/2026</a:t>
+              <a:t>07/10/2026</a:t>
             </a:fld>
             <a:endParaRPr lang="en-IE"/>
           </a:p>
@@ -22544,7 +22544,7 @@
           <p:nvPr>
             <p:extLst>
               <p:ext uri="{D42A27DB-BD31-4B8C-83A1-F6EECF244321}">
-                <p14:modId xmlns:p14="http://schemas.microsoft.com/office/powerpoint/2010/main" val="1705359239"/>
+                <p14:modId xmlns:p14="http://schemas.microsoft.com/office/powerpoint/2010/main" val="838354433"/>
               </p:ext>
             </p:extLst>
           </p:nvPr>
@@ -22893,9 +22893,10 @@
                     <a:p>
                       <a:pPr algn="ctr"/>
                       <a:r>
-                        <a:rPr lang="en-IE" sz="6600" b="1" dirty="0"/>
+                        <a:rPr lang="en-IE" sz="6600" b="1"/>
                         <a:t>Use Cases</a:t>
                       </a:r>
+                      <a:endParaRPr lang="en-IE" sz="6600" b="1" dirty="0"/>
                     </a:p>
                   </a:txBody>
                   <a:tcPr anchor="ctr">

</xml_diff>